<commit_message>
Add an optional AI assistant (offline, or Claude)
- banking_assistant.py: Assistant (abstract: conversation, retrieval)
  -> OfflineAssistant (rule-based answers, form preparation)
  -> ClaudeAssistant (Claude writes the answer via the anthropic
  package; falls back to the offline answer). It reads records and
  pre-fills one of six listed forms; it never runs an operation.
  9 tests with a stand-in for Claude; terminal chat mode
- GUI: Assistant screen (conversation, suggestions, "open the filled
  form" into Operations); OperationsPage.prefill
- Smoke test: the assistant explains a refusal, prepares a deposit form,
  the form is run and posts exactly one deposit
- CI runs the assistant tests and lints the new file
- README, report section 11.1 and figure 22, viva notes, checklist,
  progress deck slide 8 and speech; screenshots and documents rebuilt

Co-Authored-By: Claude Opus 5.5 <noreply@anthropic.com>
Claude-Session: https://claude.ai/code/session_01SahYJB3mwF36eBHRbWfj6o
</commit_message>
<xml_diff>
--- a/docs/Progress_Presentation_1.pptx
+++ b/docs/Progress_Presentation_1.pptx
@@ -1126,7 +1126,7 @@
           <a:p>
             <a:r>
               <a:rPr lang="en-US" dirty="0"/>
-              <a:t>[3:55-4:35] Ab implementation ki progress. Core model Python mein ban raha hai: parties, accounts, transactions aur double-entry ledger ka kaam ho chuka hai, aur har rule ke saath test likh raha hoon. Is waqt main cards aur lending ke workflows aur brief ke exception scenarios par kaam kar raha hoon. Saath hi Tkinter mein GUI ka prototype ban raha hai, yeh us ki screen hai, jahan staff aur customer dono apne role ke hisaab se kaam kar sakenge.</a:t>
+              <a:t>[3:55-4:35] Ab implementation ki progress. Core model Python mein ban raha hai: parties, accounts, transactions aur double-entry ledger ka kaam ho chuka hai, aur har rule ke saath test likh raha hoon. Is waqt main cards aur lending ke workflows aur brief ke exception scenarios par kaam kar raha hoon. Saath hi Tkinter mein GUI ka prototype ban raha hai, yeh us ki screen hai, jahan staff aur customer dono apne role ke hisaab se kaam kar sakenge. Aur main ek AI assistant bhi jor raha hoon, jo Claude API se bank ke records parh kar sawalon ka jawab deta hai, magar khud koi record nahi badal sakta.</a:t>
             </a:r>
             <a:endParaRPr lang="en-US" dirty="0"/>
           </a:p>
@@ -7814,6 +7814,27 @@
             </a:r>
             <a:endParaRPr lang="en-US" sz="1200" dirty="0"/>
           </a:p>
+          <a:p>
+            <a:pPr marL="342900" indent="-342900">
+              <a:spcAft>
+                <a:spcPts val="600"/>
+              </a:spcAft>
+              <a:buSzPct val="100000"/>
+              <a:buChar char="•"/>
+            </a:pPr>
+            <a:r>
+              <a:rPr lang="en-US" sz="1200" dirty="0">
+                <a:solidFill>
+                  <a:srgbClr val="1D2B2A"/>
+                </a:solidFill>
+                <a:latin typeface="Calibri" pitchFamily="34" charset="0"/>
+                <a:ea typeface="Calibri" pitchFamily="34" charset="-122"/>
+                <a:cs typeface="Calibri" pitchFamily="34" charset="-120"/>
+              </a:rPr>
+              <a:t>AI assistant (Claude) that answers from the records</a:t>
+            </a:r>
+            <a:endParaRPr lang="en-US" sz="1200" dirty="0"/>
+          </a:p>
         </p:txBody>
       </p:sp>
     </p:spTree>

</xml_diff>

<commit_message>
Step 4: progress presentation matches the repository (built and tested; now refining)
Co-Authored-By: Claude Opus 5.5 <noreply@anthropic.com>
Claude-Session: https://claude.ai/code/session_01SahYJB3mwF36eBHRbWfj6o
</commit_message>
<xml_diff>
--- a/docs/Progress_Presentation_1.pptx
+++ b/docs/Progress_Presentation_1.pptx
@@ -598,7 +598,7 @@
           <a:p>
             <a:r>
               <a:rPr lang="en-US" dirty="0"/>
-              <a:t>[0:20-0:55] Main ne project ko chhe phases mein plan kiya. Pehle teen phases mukammal hain: domain research, assumptions aur requirements, aur class aur inheritance design. Chautha phase, yani Python implementation, is waqt jaari hai, aur us ke saath Tkinter GUI par bhi kaam chal raha hai. Aakhri phase final report aur viva hai. Neeche diye gaye numbers meri research aur design ke hain: aath sources, sattaees banking terms, chhattees documented assumptions, aur ikhattar classes ka design, jin mein chaar multi-level hierarchies hain.</a:t>
+              <a:t>[0:20-0:55] Main ne project ko chhe phases mein plan kiya. Pehle chaar phases mukammal hain: research aur assumptions, class aur inheritance design, tests ke saath Python implementation, aur GUI ke saath AI assistant. Is waqt paanchwan phase, yani refinement, jaari hai, aur aakhri phase final report aur viva hai. Neeche diye gaye numbers code se liye gaye hain: aath sources, ikhattar business classes, athanve operations, solah exception scenarios, aur tehattar automated tests jo sab pass hote hain. Brief kam az kam tees classes aur tees operations maangta hai.</a:t>
             </a:r>
             <a:endParaRPr lang="en-US" dirty="0"/>
           </a:p>
@@ -1126,7 +1126,7 @@
           <a:p>
             <a:r>
               <a:rPr lang="en-US" dirty="0"/>
-              <a:t>[3:55-4:35] Ab implementation ki progress. Core model Python mein ban raha hai: parties, accounts, transactions aur double-entry ledger ka kaam ho chuka hai, aur har rule ke saath test likh raha hoon. Is waqt main cards aur lending ke workflows aur brief ke exception scenarios par kaam kar raha hoon. Saath hi Tkinter mein GUI ka prototype ban raha hai, yeh us ki screen hai, jahan staff aur customer dono apne role ke hisaab se kaam kar sakenge. Aur main ek AI assistant bhi jor raha hoon, jo Claude API se bank ke records parh kar sawalon ka jawab deta hai, magar khud koi record nahi badal sakta.</a:t>
+              <a:t>[3:55-4:35] Ab implementation. Model Python mein ban chuka hai: chaaron hierarchies, double-entry ledger jo hamesha balance rehta hai, aur brief ke solah exception scenarios, jo tehattar automated tests se check hote hain. Tkinter mein GUI bhi ban chuka hai, yeh us ki screen hai, jahan staff aur customer dono apne role ke hisaab se kaam karte hain. Aur ek AI assistant bhi hai, jo Claude API se bank ke records parh kar sawalon ka jawab deta hai, magar khud koi record nahi badal sakta. Is waqt main refinement kar raha hoon: files aur JSON se records save karna, SOLID ke mutabiq review, aur final presentation ke liye zyada wazeh diagrams.</a:t>
             </a:r>
             <a:endParaRPr lang="en-US" dirty="0"/>
           </a:p>
@@ -1214,7 +1214,7 @@
           <a:p>
             <a:r>
               <a:rPr lang="en-US" dirty="0"/>
-              <a:t>[4:35-5:00] Agle steps: implementation aur GUI mukammal karna, brief ke har critical case ko automated tests se check karna, files aur JSON se data save karna, aur SOLID principles ke mutabiq design review karna. Aakhir mein final report aur viva. Shukriya, main sawalat ke liye hazir hoon.</a:t>
+              <a:t>[4:35-5:00] Agle steps: pehle files aur JSON se bank ke records save aur load karna, phir SOLID aur design patterns ke mutabiq design review, phir aaj ke feedback par amal. Aakhir mein final report aur viva. Shukriya, main sawalat ke liye hazir hoon.</a:t>
             </a:r>
             <a:endParaRPr lang="en-US" dirty="0"/>
           </a:p>
@@ -1864,7 +1864,7 @@
                 <a:ea typeface="Calibri" pitchFamily="34" charset="-122"/>
                 <a:cs typeface="Calibri" pitchFamily="34" charset="-120"/>
               </a:rPr>
-              <a:t>Six planned phases: research and design complete, implementation and GUI under way</a:t>
+              <a:t>Six planned phases: four complete, refinement under way, then the final submission</a:t>
             </a:r>
             <a:endParaRPr lang="en-US" sz="1200" dirty="0"/>
           </a:p>
@@ -2085,7 +2085,7 @@
                 <a:ea typeface="Calibri" pitchFamily="34" charset="-122"/>
                 <a:cs typeface="Calibri" pitchFamily="34" charset="-120"/>
               </a:rPr>
-              <a:t>Domain research</a:t>
+              <a:t>Domain research &amp; assumptions</a:t>
             </a:r>
             <a:endParaRPr lang="en-US" sz="1100" dirty="0"/>
           </a:p>
@@ -2227,7 +2227,7 @@
                 <a:ea typeface="Calibri" pitchFamily="34" charset="-122"/>
                 <a:cs typeface="Calibri" pitchFamily="34" charset="-120"/>
               </a:rPr>
-              <a:t>Assumptions &amp; requirements</a:t>
+              <a:t>Class &amp; inheritance design</a:t>
             </a:r>
             <a:endParaRPr lang="en-US" sz="1100" dirty="0"/>
           </a:p>
@@ -2369,7 +2369,7 @@
                 <a:ea typeface="Calibri" pitchFamily="34" charset="-122"/>
                 <a:cs typeface="Calibri" pitchFamily="34" charset="-120"/>
               </a:rPr>
-              <a:t>Class &amp; inheritance design</a:t>
+              <a:t>Implementation + tests</a:t>
             </a:r>
             <a:endParaRPr lang="en-US" sz="1100" dirty="0"/>
           </a:p>
@@ -2423,6 +2423,148 @@
         <p:spPr>
           <a:xfrm>
             <a:off x="5129784" y="1554480"/>
+            <a:ext cx="365760" cy="365760"/>
+          </a:xfrm>
+          <a:prstGeom prst="ellipse">
+            <a:avLst/>
+          </a:prstGeom>
+          <a:solidFill>
+            <a:srgbClr val="2E7D4F"/>
+          </a:solidFill>
+          <a:ln w="25400">
+            <a:solidFill>
+              <a:srgbClr val="FFFFFF"/>
+            </a:solidFill>
+            <a:prstDash val="solid"/>
+          </a:ln>
+        </p:spPr>
+      </p:sp>
+      <p:sp>
+        <p:nvSpPr>
+          <p:cNvPr id="19" name="Text 17"/>
+          <p:cNvSpPr txBox="1"/>
+          <p:nvPr/>
+        </p:nvSpPr>
+        <p:spPr>
+          <a:xfrm>
+            <a:off x="5129784" y="1554480"/>
+            <a:ext cx="365760" cy="365760"/>
+          </a:xfrm>
+          <a:prstGeom prst="rect">
+            <a:avLst/>
+          </a:prstGeom>
+          <a:noFill/>
+          <a:ln/>
+        </p:spPr>
+        <p:txBody>
+          <a:bodyPr wrap="square" lIns="0" tIns="0" rIns="0" bIns="0" rtlCol="0" anchor="ctr"/>
+          <a:lstStyle/>
+          <a:p>
+            <a:pPr algn="ctr" indent="0" marL="0">
+              <a:buNone/>
+            </a:pPr>
+            <a:r>
+              <a:rPr lang="en-US" sz="1300" b="1" dirty="0">
+                <a:solidFill>
+                  <a:srgbClr val="FFFFFF"/>
+                </a:solidFill>
+                <a:latin typeface="Cambria" pitchFamily="34" charset="0"/>
+                <a:ea typeface="Cambria" pitchFamily="34" charset="-122"/>
+                <a:cs typeface="Cambria" pitchFamily="34" charset="-120"/>
+              </a:rPr>
+              <a:t>4</a:t>
+            </a:r>
+            <a:endParaRPr lang="en-US" sz="1300" dirty="0"/>
+          </a:p>
+        </p:txBody>
+      </p:sp>
+      <p:sp>
+        <p:nvSpPr>
+          <p:cNvPr id="20" name="Text 18"/>
+          <p:cNvSpPr txBox="1"/>
+          <p:nvPr/>
+        </p:nvSpPr>
+        <p:spPr>
+          <a:xfrm>
+            <a:off x="4626864" y="2011680"/>
+            <a:ext cx="1371600" cy="502920"/>
+          </a:xfrm>
+          <a:prstGeom prst="rect">
+            <a:avLst/>
+          </a:prstGeom>
+          <a:noFill/>
+          <a:ln/>
+        </p:spPr>
+        <p:txBody>
+          <a:bodyPr wrap="square" lIns="0" tIns="0" rIns="0" bIns="0" rtlCol="0" anchor="t"/>
+          <a:lstStyle/>
+          <a:p>
+            <a:pPr algn="ctr" indent="0" marL="0">
+              <a:buNone/>
+            </a:pPr>
+            <a:r>
+              <a:rPr lang="en-US" sz="1100" b="1" dirty="0">
+                <a:solidFill>
+                  <a:srgbClr val="1D2B2A"/>
+                </a:solidFill>
+                <a:latin typeface="Calibri" pitchFamily="34" charset="0"/>
+                <a:ea typeface="Calibri" pitchFamily="34" charset="-122"/>
+                <a:cs typeface="Calibri" pitchFamily="34" charset="-120"/>
+              </a:rPr>
+              <a:t>GUI + AI assistant</a:t>
+            </a:r>
+            <a:endParaRPr lang="en-US" sz="1100" dirty="0"/>
+          </a:p>
+        </p:txBody>
+      </p:sp>
+      <p:sp>
+        <p:nvSpPr>
+          <p:cNvPr id="21" name="Text 19"/>
+          <p:cNvSpPr txBox="1"/>
+          <p:nvPr/>
+        </p:nvSpPr>
+        <p:spPr>
+          <a:xfrm>
+            <a:off x="4626864" y="2514600"/>
+            <a:ext cx="1371600" cy="228600"/>
+          </a:xfrm>
+          <a:prstGeom prst="rect">
+            <a:avLst/>
+          </a:prstGeom>
+          <a:noFill/>
+          <a:ln/>
+        </p:spPr>
+        <p:txBody>
+          <a:bodyPr wrap="square" lIns="0" tIns="0" rIns="0" bIns="0" rtlCol="0" anchor="ctr"/>
+          <a:lstStyle/>
+          <a:p>
+            <a:pPr algn="ctr" indent="0" marL="0">
+              <a:buNone/>
+            </a:pPr>
+            <a:r>
+              <a:rPr lang="en-US" sz="1050" dirty="0">
+                <a:solidFill>
+                  <a:srgbClr val="2E7D4F"/>
+                </a:solidFill>
+                <a:latin typeface="Calibri" pitchFamily="34" charset="0"/>
+                <a:ea typeface="Calibri" pitchFamily="34" charset="-122"/>
+                <a:cs typeface="Calibri" pitchFamily="34" charset="-120"/>
+              </a:rPr>
+              <a:t>Done</a:t>
+            </a:r>
+            <a:endParaRPr lang="en-US" sz="1050" dirty="0"/>
+          </a:p>
+        </p:txBody>
+      </p:sp>
+      <p:sp>
+        <p:nvSpPr>
+          <p:cNvPr id="22" name="Shape 20"/>
+          <p:cNvSpPr/>
+          <p:nvPr/>
+        </p:nvSpPr>
+        <p:spPr>
+          <a:xfrm>
+            <a:off x="6611112" y="1554480"/>
             <a:ext cx="365760" cy="365760"/>
           </a:xfrm>
           <a:prstGeom prst="ellipse">
@@ -2441,13 +2583,13 @@
       </p:sp>
       <p:sp>
         <p:nvSpPr>
-          <p:cNvPr id="19" name="Text 17"/>
-          <p:cNvSpPr txBox="1"/>
-          <p:nvPr/>
-        </p:nvSpPr>
-        <p:spPr>
-          <a:xfrm>
-            <a:off x="5129784" y="1554480"/>
+          <p:cNvPr id="23" name="Text 21"/>
+          <p:cNvSpPr txBox="1"/>
+          <p:nvPr/>
+        </p:nvSpPr>
+        <p:spPr>
+          <a:xfrm>
+            <a:off x="6611112" y="1554480"/>
             <a:ext cx="365760" cy="365760"/>
           </a:xfrm>
           <a:prstGeom prst="rect">
@@ -2472,148 +2614,6 @@
                 <a:ea typeface="Cambria" pitchFamily="34" charset="-122"/>
                 <a:cs typeface="Cambria" pitchFamily="34" charset="-120"/>
               </a:rPr>
-              <a:t>4</a:t>
-            </a:r>
-            <a:endParaRPr lang="en-US" sz="1300" dirty="0"/>
-          </a:p>
-        </p:txBody>
-      </p:sp>
-      <p:sp>
-        <p:nvSpPr>
-          <p:cNvPr id="20" name="Text 18"/>
-          <p:cNvSpPr txBox="1"/>
-          <p:nvPr/>
-        </p:nvSpPr>
-        <p:spPr>
-          <a:xfrm>
-            <a:off x="4626864" y="2011680"/>
-            <a:ext cx="1371600" cy="502920"/>
-          </a:xfrm>
-          <a:prstGeom prst="rect">
-            <a:avLst/>
-          </a:prstGeom>
-          <a:noFill/>
-          <a:ln/>
-        </p:spPr>
-        <p:txBody>
-          <a:bodyPr wrap="square" lIns="0" tIns="0" rIns="0" bIns="0" rtlCol="0" anchor="t"/>
-          <a:lstStyle/>
-          <a:p>
-            <a:pPr algn="ctr" indent="0" marL="0">
-              <a:buNone/>
-            </a:pPr>
-            <a:r>
-              <a:rPr lang="en-US" sz="1100" b="1" dirty="0">
-                <a:solidFill>
-                  <a:srgbClr val="1D2B2A"/>
-                </a:solidFill>
-                <a:latin typeface="Calibri" pitchFamily="34" charset="0"/>
-                <a:ea typeface="Calibri" pitchFamily="34" charset="-122"/>
-                <a:cs typeface="Calibri" pitchFamily="34" charset="-120"/>
-              </a:rPr>
-              <a:t>Implementation (Python)</a:t>
-            </a:r>
-            <a:endParaRPr lang="en-US" sz="1100" dirty="0"/>
-          </a:p>
-        </p:txBody>
-      </p:sp>
-      <p:sp>
-        <p:nvSpPr>
-          <p:cNvPr id="21" name="Text 19"/>
-          <p:cNvSpPr txBox="1"/>
-          <p:nvPr/>
-        </p:nvSpPr>
-        <p:spPr>
-          <a:xfrm>
-            <a:off x="4626864" y="2514600"/>
-            <a:ext cx="1371600" cy="228600"/>
-          </a:xfrm>
-          <a:prstGeom prst="rect">
-            <a:avLst/>
-          </a:prstGeom>
-          <a:noFill/>
-          <a:ln/>
-        </p:spPr>
-        <p:txBody>
-          <a:bodyPr wrap="square" lIns="0" tIns="0" rIns="0" bIns="0" rtlCol="0" anchor="ctr"/>
-          <a:lstStyle/>
-          <a:p>
-            <a:pPr algn="ctr" indent="0" marL="0">
-              <a:buNone/>
-            </a:pPr>
-            <a:r>
-              <a:rPr lang="en-US" sz="1050" dirty="0">
-                <a:solidFill>
-                  <a:srgbClr val="C98A12"/>
-                </a:solidFill>
-                <a:latin typeface="Calibri" pitchFamily="34" charset="0"/>
-                <a:ea typeface="Calibri" pitchFamily="34" charset="-122"/>
-                <a:cs typeface="Calibri" pitchFamily="34" charset="-120"/>
-              </a:rPr>
-              <a:t>In progress</a:t>
-            </a:r>
-            <a:endParaRPr lang="en-US" sz="1050" dirty="0"/>
-          </a:p>
-        </p:txBody>
-      </p:sp>
-      <p:sp>
-        <p:nvSpPr>
-          <p:cNvPr id="22" name="Shape 20"/>
-          <p:cNvSpPr/>
-          <p:nvPr/>
-        </p:nvSpPr>
-        <p:spPr>
-          <a:xfrm>
-            <a:off x="6611112" y="1554480"/>
-            <a:ext cx="365760" cy="365760"/>
-          </a:xfrm>
-          <a:prstGeom prst="ellipse">
-            <a:avLst/>
-          </a:prstGeom>
-          <a:solidFill>
-            <a:srgbClr val="C98A12"/>
-          </a:solidFill>
-          <a:ln w="25400">
-            <a:solidFill>
-              <a:srgbClr val="FFFFFF"/>
-            </a:solidFill>
-            <a:prstDash val="solid"/>
-          </a:ln>
-        </p:spPr>
-      </p:sp>
-      <p:sp>
-        <p:nvSpPr>
-          <p:cNvPr id="23" name="Text 21"/>
-          <p:cNvSpPr txBox="1"/>
-          <p:nvPr/>
-        </p:nvSpPr>
-        <p:spPr>
-          <a:xfrm>
-            <a:off x="6611112" y="1554480"/>
-            <a:ext cx="365760" cy="365760"/>
-          </a:xfrm>
-          <a:prstGeom prst="rect">
-            <a:avLst/>
-          </a:prstGeom>
-          <a:noFill/>
-          <a:ln/>
-        </p:spPr>
-        <p:txBody>
-          <a:bodyPr wrap="square" lIns="0" tIns="0" rIns="0" bIns="0" rtlCol="0" anchor="ctr"/>
-          <a:lstStyle/>
-          <a:p>
-            <a:pPr algn="ctr" indent="0" marL="0">
-              <a:buNone/>
-            </a:pPr>
-            <a:r>
-              <a:rPr lang="en-US" sz="1300" b="1" dirty="0">
-                <a:solidFill>
-                  <a:srgbClr val="FFFFFF"/>
-                </a:solidFill>
-                <a:latin typeface="Cambria" pitchFamily="34" charset="0"/>
-                <a:ea typeface="Cambria" pitchFamily="34" charset="-122"/>
-                <a:cs typeface="Cambria" pitchFamily="34" charset="-120"/>
-              </a:rPr>
               <a:t>5</a:t>
             </a:r>
             <a:endParaRPr lang="en-US" sz="1300" dirty="0"/>
@@ -2653,7 +2653,7 @@
                 <a:ea typeface="Calibri" pitchFamily="34" charset="-122"/>
                 <a:cs typeface="Calibri" pitchFamily="34" charset="-120"/>
               </a:rPr>
-              <a:t>GUI (Tkinter)</a:t>
+              <a:t>Refinement: JSON, SOLID</a:t>
             </a:r>
             <a:endParaRPr lang="en-US" sz="1100" dirty="0"/>
           </a:p>
@@ -3005,7 +3005,7 @@
                 <a:ea typeface="Cambria" pitchFamily="34" charset="-122"/>
                 <a:cs typeface="Cambria" pitchFamily="34" charset="-120"/>
               </a:rPr>
-              <a:t>27</a:t>
+              <a:t>71</a:t>
             </a:r>
             <a:endParaRPr lang="en-US" sz="3400" dirty="0"/>
           </a:p>
@@ -3044,7 +3044,7 @@
                 <a:ea typeface="Calibri" pitchFamily="34" charset="-122"/>
                 <a:cs typeface="Calibri" pitchFamily="34" charset="-120"/>
               </a:rPr>
-              <a:t>banking terms defined</a:t>
+              <a:t>business classes</a:t>
             </a:r>
             <a:endParaRPr lang="en-US" sz="1150" dirty="0"/>
           </a:p>
@@ -3110,7 +3110,7 @@
                 <a:ea typeface="Cambria" pitchFamily="34" charset="-122"/>
                 <a:cs typeface="Cambria" pitchFamily="34" charset="-120"/>
               </a:rPr>
-              <a:t>36</a:t>
+              <a:t>98</a:t>
             </a:r>
             <a:endParaRPr lang="en-US" sz="3400" dirty="0"/>
           </a:p>
@@ -3149,7 +3149,7 @@
                 <a:ea typeface="Calibri" pitchFamily="34" charset="-122"/>
                 <a:cs typeface="Calibri" pitchFamily="34" charset="-120"/>
               </a:rPr>
-              <a:t>documented assumptions</a:t>
+              <a:t>operations</a:t>
             </a:r>
             <a:endParaRPr lang="en-US" sz="1150" dirty="0"/>
           </a:p>
@@ -3215,7 +3215,7 @@
                 <a:ea typeface="Cambria" pitchFamily="34" charset="-122"/>
                 <a:cs typeface="Cambria" pitchFamily="34" charset="-120"/>
               </a:rPr>
-              <a:t>71</a:t>
+              <a:t>16</a:t>
             </a:r>
             <a:endParaRPr lang="en-US" sz="3400" dirty="0"/>
           </a:p>
@@ -3254,7 +3254,7 @@
                 <a:ea typeface="Calibri" pitchFamily="34" charset="-122"/>
                 <a:cs typeface="Calibri" pitchFamily="34" charset="-120"/>
               </a:rPr>
-              <a:t>classes designed</a:t>
+              <a:t>exception scenarios</a:t>
             </a:r>
             <a:endParaRPr lang="en-US" sz="1150" dirty="0"/>
           </a:p>
@@ -3320,7 +3320,7 @@
                 <a:ea typeface="Cambria" pitchFamily="34" charset="-122"/>
                 <a:cs typeface="Cambria" pitchFamily="34" charset="-120"/>
               </a:rPr>
-              <a:t>4</a:t>
+              <a:t>73</a:t>
             </a:r>
             <a:endParaRPr lang="en-US" sz="3400" dirty="0"/>
           </a:p>
@@ -3359,7 +3359,7 @@
                 <a:ea typeface="Calibri" pitchFamily="34" charset="-122"/>
                 <a:cs typeface="Calibri" pitchFamily="34" charset="-120"/>
               </a:rPr>
-              <a:t>multi-level hierarchies</a:t>
+              <a:t>automated tests</a:t>
             </a:r>
             <a:endParaRPr lang="en-US" sz="1150" dirty="0"/>
           </a:p>
@@ -3398,7 +3398,7 @@
                 <a:ea typeface="Calibri" pitchFamily="34" charset="-122"/>
                 <a:cs typeface="Calibri" pitchFamily="34" charset="-120"/>
               </a:rPr>
-              <a:t>The brief asks for at least 30 meaningful classes and one multi-level hierarchy</a:t>
+              <a:t>The brief asks for at least 30 meaningful classes, 30 operations and one multi-level hierarchy</a:t>
             </a:r>
             <a:endParaRPr lang="en-US" sz="1100" dirty="0"/>
           </a:p>
@@ -7303,7 +7303,7 @@
               <a:buNone/>
             </a:pPr>
             <a:r>
-              <a:rPr lang="en-US" sz="2600" b="1" dirty="0">
+              <a:rPr lang="en-US" sz="2300" b="1" dirty="0">
                 <a:solidFill>
                   <a:srgbClr val="0B4F4A"/>
                 </a:solidFill>
@@ -7311,9 +7311,9 @@
                 <a:ea typeface="Cambria" pitchFamily="34" charset="-122"/>
                 <a:cs typeface="Cambria" pitchFamily="34" charset="-120"/>
               </a:rPr>
-              <a:t>Implementation and GUI: in progress</a:t>
-            </a:r>
-            <a:endParaRPr lang="en-US" sz="2600" dirty="0"/>
+              <a:t>Implementation and GUI: built and tested</a:t>
+            </a:r>
+            <a:endParaRPr lang="en-US" sz="2300" dirty="0"/>
           </a:p>
         </p:txBody>
       </p:sp>
@@ -7589,7 +7589,7 @@
         <p:spPr>
           <a:xfrm>
             <a:off x="5212080" y="1618488"/>
-            <a:ext cx="3566160" cy="1234440"/>
+            <a:ext cx="3566160" cy="1536192"/>
           </a:xfrm>
           <a:prstGeom prst="rect">
             <a:avLst/>
@@ -7617,7 +7617,7 @@
                 <a:ea typeface="Calibri" pitchFamily="34" charset="-122"/>
                 <a:cs typeface="Calibri" pitchFamily="34" charset="-120"/>
               </a:rPr>
-              <a:t>Party, Arrangement and Transaction hierarchies</a:t>
+              <a:t>Four hierarchies; double-entry ledger that always balances</a:t>
             </a:r>
             <a:endParaRPr lang="en-US" sz="1200" dirty="0"/>
           </a:p>
@@ -7638,7 +7638,7 @@
                 <a:ea typeface="Calibri" pitchFamily="34" charset="-122"/>
                 <a:cs typeface="Calibri" pitchFamily="34" charset="-120"/>
               </a:rPr>
-              <a:t>Double-entry ledger: balances derived, never stored</a:t>
+              <a:t>16 exception scenarios, 73 automated tests</a:t>
             </a:r>
             <a:endParaRPr lang="en-US" sz="1200" dirty="0"/>
           </a:p>
@@ -7659,7 +7659,28 @@
                 <a:ea typeface="Calibri" pitchFamily="34" charset="-122"/>
                 <a:cs typeface="Calibri" pitchFamily="34" charset="-120"/>
               </a:rPr>
-              <a:t>KYC checks and dated mandates</a:t>
+              <a:t>GUI for staff and for customers</a:t>
+            </a:r>
+            <a:endParaRPr lang="en-US" sz="1200" dirty="0"/>
+          </a:p>
+          <a:p>
+            <a:pPr marL="342900" indent="-342900">
+              <a:spcAft>
+                <a:spcPts val="600"/>
+              </a:spcAft>
+              <a:buSzPct val="100000"/>
+              <a:buChar char="•"/>
+            </a:pPr>
+            <a:r>
+              <a:rPr lang="en-US" sz="1200" dirty="0">
+                <a:solidFill>
+                  <a:srgbClr val="1D2B2A"/>
+                </a:solidFill>
+                <a:latin typeface="Calibri" pitchFamily="34" charset="0"/>
+                <a:ea typeface="Calibri" pitchFamily="34" charset="-122"/>
+                <a:cs typeface="Calibri" pitchFamily="34" charset="-120"/>
+              </a:rPr>
+              <a:t>AI assistant (Claude) that answers from the records</a:t>
             </a:r>
             <a:endParaRPr lang="en-US" sz="1200" dirty="0"/>
           </a:p>
@@ -7673,7 +7694,7 @@
         </p:nvSpPr>
         <p:spPr>
           <a:xfrm>
-            <a:off x="5212080" y="2926080"/>
+            <a:off x="5212080" y="3383280"/>
             <a:ext cx="1188720" cy="310896"/>
           </a:xfrm>
           <a:prstGeom prst="roundRect">
@@ -7700,7 +7721,7 @@
         </p:nvSpPr>
         <p:spPr>
           <a:xfrm>
-            <a:off x="5212080" y="2926080"/>
+            <a:off x="5212080" y="3383280"/>
             <a:ext cx="1188720" cy="310896"/>
           </a:xfrm>
           <a:prstGeom prst="rect">
@@ -7725,7 +7746,7 @@
                 <a:ea typeface="Calibri" pitchFamily="34" charset="-122"/>
                 <a:cs typeface="Calibri" pitchFamily="34" charset="-120"/>
               </a:rPr>
-              <a:t>In progress</a:t>
+              <a:t>Now refining</a:t>
             </a:r>
             <a:endParaRPr lang="en-US" sz="1150" dirty="0"/>
           </a:p>
@@ -7739,8 +7760,8 @@
         </p:nvSpPr>
         <p:spPr>
           <a:xfrm>
-            <a:off x="5212080" y="3310128"/>
-            <a:ext cx="3566160" cy="1234440"/>
+            <a:off x="5212080" y="3767328"/>
+            <a:ext cx="3566160" cy="1152144"/>
           </a:xfrm>
           <a:prstGeom prst="rect">
             <a:avLst/>
@@ -7768,7 +7789,7 @@
                 <a:ea typeface="Calibri" pitchFamily="34" charset="-122"/>
                 <a:cs typeface="Calibri" pitchFamily="34" charset="-120"/>
               </a:rPr>
-              <a:t>Card and lending workflows</a:t>
+              <a:t>Saving and loading records (files / JSON)</a:t>
             </a:r>
             <a:endParaRPr lang="en-US" sz="1200" dirty="0"/>
           </a:p>
@@ -7789,7 +7810,7 @@
                 <a:ea typeface="Calibri" pitchFamily="34" charset="-122"/>
                 <a:cs typeface="Calibri" pitchFamily="34" charset="-120"/>
               </a:rPr>
-              <a:t>Exception scenarios from the brief</a:t>
+              <a:t>Design review against SOLID</a:t>
             </a:r>
             <a:endParaRPr lang="en-US" sz="1200" dirty="0"/>
           </a:p>
@@ -7810,28 +7831,7 @@
                 <a:ea typeface="Calibri" pitchFamily="34" charset="-122"/>
                 <a:cs typeface="Calibri" pitchFamily="34" charset="-120"/>
               </a:rPr>
-              <a:t>GUI screens for staff and customers</a:t>
-            </a:r>
-            <a:endParaRPr lang="en-US" sz="1200" dirty="0"/>
-          </a:p>
-          <a:p>
-            <a:pPr marL="342900" indent="-342900">
-              <a:spcAft>
-                <a:spcPts val="600"/>
-              </a:spcAft>
-              <a:buSzPct val="100000"/>
-              <a:buChar char="•"/>
-            </a:pPr>
-            <a:r>
-              <a:rPr lang="en-US" sz="1200" dirty="0">
-                <a:solidFill>
-                  <a:srgbClr val="1D2B2A"/>
-                </a:solidFill>
-                <a:latin typeface="Calibri" pitchFamily="34" charset="0"/>
-                <a:ea typeface="Calibri" pitchFamily="34" charset="-122"/>
-                <a:cs typeface="Calibri" pitchFamily="34" charset="-120"/>
-              </a:rPr>
-              <a:t>AI assistant (Claude) that answers from the records</a:t>
+              <a:t>Clearer diagrams for the final presentation</a:t>
             </a:r>
             <a:endParaRPr lang="en-US" sz="1200" dirty="0"/>
           </a:p>
@@ -8168,7 +8168,7 @@
                 <a:ea typeface="Calibri" pitchFamily="34" charset="-122"/>
                 <a:cs typeface="Calibri" pitchFamily="34" charset="-120"/>
               </a:rPr>
-              <a:t>Finish the implementation and GUI screens</a:t>
+              <a:t>Save and load the bank's records with files / JSON (weeks 6, 11)</a:t>
             </a:r>
             <a:endParaRPr lang="en-US" sz="1400" dirty="0"/>
           </a:p>
@@ -8300,7 +8300,7 @@
                 <a:ea typeface="Calibri" pitchFamily="34" charset="-122"/>
                 <a:cs typeface="Calibri" pitchFamily="34" charset="-120"/>
               </a:rPr>
-              <a:t>Test every critical case from the brief with automated tests</a:t>
+              <a:t>Review the design against SOLID and the design patterns (weeks 10, 11)</a:t>
             </a:r>
             <a:endParaRPr lang="en-US" sz="1400" dirty="0"/>
           </a:p>
@@ -8432,7 +8432,7 @@
                 <a:ea typeface="Calibri" pitchFamily="34" charset="-122"/>
                 <a:cs typeface="Calibri" pitchFamily="34" charset="-120"/>
               </a:rPr>
-              <a:t>Save and load records with files / JSON; review against SOLID (weeks 6, 11)</a:t>
+              <a:t>Apply the feedback from this checkpoint</a:t>
             </a:r>
             <a:endParaRPr lang="en-US" sz="1400" dirty="0"/>
           </a:p>

</xml_diff>

<commit_message>
Step 7: large presentation diagrams (overview + one per hierarchy), checked against the code
Co-Authored-By: Claude Opus 5.5 <noreply@anthropic.com>
Claude-Session: https://claude.ai/code/session_01SahYJB3mwF36eBHRbWfj6o
</commit_message>
<xml_diff>
--- a/docs/Progress_Presentation_1.pptx
+++ b/docs/Progress_Presentation_1.pptx
@@ -5878,7 +5878,7 @@
       </p:sp>
       <p:pic>
         <p:nvPicPr>
-          <p:cNvPr id="5" name="Image 0" descr="/home/user/commercial-banking/docs/class_diagram.png">    </p:cNvPr>
+          <p:cNvPr id="5" name="Image 0" descr="/home/user/commercial-banking/docs/slide_overview.png">    </p:cNvPr>
           <p:cNvPicPr>
             <a:picLocks noChangeAspect="1"/>
           </p:cNvPicPr>
@@ -5892,8 +5892,8 @@
         </p:blipFill>
         <p:spPr>
           <a:xfrm>
-            <a:off x="380426" y="1188720"/>
-            <a:ext cx="8383148" cy="3429000"/>
+            <a:off x="1524000" y="1188720"/>
+            <a:ext cx="6096000" cy="3429000"/>
           </a:xfrm>
           <a:prstGeom prst="rect">
             <a:avLst/>
@@ -5933,7 +5933,7 @@
                 <a:ea typeface="Calibri" pitchFamily="34" charset="-122"/>
                 <a:cs typeface="Calibri" pitchFamily="34" charset="-120"/>
               </a:rPr>
-              <a:t>Inheritance only for a true “is-a”; everything else is association</a:t>
+              <a:t>Inheritance only for a true “is-a”; everything else is association. Full UML in the design report</a:t>
             </a:r>
             <a:endParaRPr lang="en-US" sz="1050" dirty="0"/>
           </a:p>

</xml_diff>

<commit_message>
Step 10: save and load the whole bank as JSON
- Repository (abstract: shared JSON format, save/load template methods)
  -> JsonFileRepository / MemoryRepository; links saved as references,
  dates/Decimals/tuples/frozensets typed, lifecycles saved by name,
  reference counters restored; iterative encoding (no deep recursion)
- 4 tests (77 in total): exact round trip of all 1,366 demo objects,
  history kept, loaded bank carries on, file repository
- CLI --save FILE / --load FILE; GUI Save and Open in the top bar;
  smoke test saves, changes and reopens the bank
- Report 5.2 and limitations, counts (80 classes: 71 business + 9
  supporting; 77 tests) across README, checklist, code review, viva notes,
  decks, flowchart 1 and the progress speech; diagrams and screenshots
  regenerated

Co-Authored-By: Claude Opus 5.5 <noreply@anthropic.com>
Claude-Session: https://claude.ai/code/session_01SahYJB3mwF36eBHRbWfj6o
</commit_message>
<xml_diff>
--- a/docs/Progress_Presentation_1.pptx
+++ b/docs/Progress_Presentation_1.pptx
@@ -598,7 +598,7 @@
           <a:p>
             <a:r>
               <a:rPr lang="en-US" dirty="0"/>
-              <a:t>[0:20-0:55] Main ne project ko chhe phases mein plan kiya. Pehle chaar phases mukammal hain: research aur assumptions, class aur inheritance design, tests ke saath Python implementation, aur GUI ke saath AI assistant. Is waqt paanchwan phase, yani refinement, jaari hai, aur aakhri phase final report aur viva hai. Neeche diye gaye numbers code se liye gaye hain: aath sources, ikhattar business classes, athanve operations, solah exception scenarios, aur tehattar automated tests jo sab pass hote hain. Brief kam az kam tees classes aur tees operations maangta hai.</a:t>
+              <a:t>[0:20-0:55] Main ne project ko chhe phases mein plan kiya. Pehle chaar phases mukammal hain: research aur assumptions, class aur inheritance design, tests ke saath Python implementation, aur GUI ke saath AI assistant. Is waqt paanchwan phase, yani refinement, jaari hai, aur aakhri phase final report aur viva hai. Neeche diye gaye numbers code se liye gaye hain: aath sources, ikhattar business classes, athanve operations, solah exception scenarios, aur sattattar automated tests jo sab pass hote hain. Brief kam az kam tees classes aur tees operations maangta hai.</a:t>
             </a:r>
             <a:endParaRPr lang="en-US" dirty="0"/>
           </a:p>
@@ -1126,7 +1126,7 @@
           <a:p>
             <a:r>
               <a:rPr lang="en-US" dirty="0"/>
-              <a:t>[3:55-4:35] Ab implementation. Model Python mein ban chuka hai: chaaron hierarchies, double-entry ledger jo hamesha balance rehta hai, aur brief ke solah exception scenarios, jo tehattar automated tests se check hote hain. Tkinter mein GUI bhi ban chuka hai, yeh us ki screen hai, jahan staff aur customer dono apne role ke hisaab se kaam karte hain. Aur ek AI assistant bhi hai, jo Claude API se bank ke records parh kar sawalon ka jawab deta hai, magar khud koi record nahi badal sakta. Is waqt main refinement kar raha hoon: files aur JSON se records save karna, SOLID ke mutabiq review, aur final presentation ke liye zyada wazeh diagrams.</a:t>
+              <a:t>[3:55-4:35] Ab implementation. Model Python mein ban chuka hai: chaaron hierarchies, double-entry ledger jo hamesha balance rehta hai, aur brief ke solah exception scenarios, jo sattattar automated tests se check hote hain. Tkinter mein GUI bhi ban chuka hai, yeh us ki screen hai, jahan staff aur customer dono apne role ke hisaab se kaam karte hain. Aur ek AI assistant bhi hai, jo Claude API se bank ke records parh kar sawalon ka jawab deta hai, magar khud koi record nahi badal sakta. Poora bank ek JSON file mein save aur dobara load bhi ho jata hai. Is waqt main refinement kar raha hoon: SOLID aur design patterns ke mutabiq review, aur final presentation ki tayyari.</a:t>
             </a:r>
             <a:endParaRPr lang="en-US" dirty="0"/>
           </a:p>
@@ -1214,7 +1214,7 @@
           <a:p>
             <a:r>
               <a:rPr lang="en-US" dirty="0"/>
-              <a:t>[4:35-5:00] Agle steps: pehle files aur JSON se bank ke records save aur load karna, phir SOLID aur design patterns ke mutabiq design review, phir aaj ke feedback par amal. Aakhir mein final report aur viva. Shukriya, main sawalat ke liye hazir hoon.</a:t>
+              <a:t>[4:35-5:00] Agle steps: pehle SOLID aur design patterns ke mutabiq design review, phir aaj ke feedback par amal, phir final presentation aur live demo ki tayyari. Aakhir mein final report aur viva. Shukriya, main sawalat ke liye hazir hoon.</a:t>
             </a:r>
             <a:endParaRPr lang="en-US" dirty="0"/>
           </a:p>
@@ -2653,7 +2653,7 @@
                 <a:ea typeface="Calibri" pitchFamily="34" charset="-122"/>
                 <a:cs typeface="Calibri" pitchFamily="34" charset="-120"/>
               </a:rPr>
-              <a:t>Refinement: JSON, SOLID</a:t>
+              <a:t>Refinement: SOLID review</a:t>
             </a:r>
             <a:endParaRPr lang="en-US" sz="1100" dirty="0"/>
           </a:p>
@@ -3320,7 +3320,7 @@
                 <a:ea typeface="Cambria" pitchFamily="34" charset="-122"/>
                 <a:cs typeface="Cambria" pitchFamily="34" charset="-120"/>
               </a:rPr>
-              <a:t>73</a:t>
+              <a:t>77</a:t>
             </a:r>
             <a:endParaRPr lang="en-US" sz="3400" dirty="0"/>
           </a:p>
@@ -7638,7 +7638,7 @@
                 <a:ea typeface="Calibri" pitchFamily="34" charset="-122"/>
                 <a:cs typeface="Calibri" pitchFamily="34" charset="-120"/>
               </a:rPr>
-              <a:t>16 exception scenarios, 73 automated tests</a:t>
+              <a:t>16 exception scenarios, 77 automated tests</a:t>
             </a:r>
             <a:endParaRPr lang="en-US" sz="1200" dirty="0"/>
           </a:p>
@@ -7659,7 +7659,7 @@
                 <a:ea typeface="Calibri" pitchFamily="34" charset="-122"/>
                 <a:cs typeface="Calibri" pitchFamily="34" charset="-120"/>
               </a:rPr>
-              <a:t>GUI for staff and for customers</a:t>
+              <a:t>GUI for staff and customers; AI assistant</a:t>
             </a:r>
             <a:endParaRPr lang="en-US" sz="1200" dirty="0"/>
           </a:p>
@@ -7680,7 +7680,7 @@
                 <a:ea typeface="Calibri" pitchFamily="34" charset="-122"/>
                 <a:cs typeface="Calibri" pitchFamily="34" charset="-120"/>
               </a:rPr>
-              <a:t>AI assistant (Claude) that answers from the records</a:t>
+              <a:t>Save and load the whole bank (JSON file)</a:t>
             </a:r>
             <a:endParaRPr lang="en-US" sz="1200" dirty="0"/>
           </a:p>
@@ -7761,7 +7761,7 @@
         <p:spPr>
           <a:xfrm>
             <a:off x="5212080" y="3767328"/>
-            <a:ext cx="3566160" cy="1152144"/>
+            <a:ext cx="3566160" cy="768096"/>
           </a:xfrm>
           <a:prstGeom prst="rect">
             <a:avLst/>
@@ -7789,7 +7789,7 @@
                 <a:ea typeface="Calibri" pitchFamily="34" charset="-122"/>
                 <a:cs typeface="Calibri" pitchFamily="34" charset="-120"/>
               </a:rPr>
-              <a:t>Saving and loading records (files / JSON)</a:t>
+              <a:t>Design review against SOLID and design patterns</a:t>
             </a:r>
             <a:endParaRPr lang="en-US" sz="1200" dirty="0"/>
           </a:p>
@@ -7810,28 +7810,7 @@
                 <a:ea typeface="Calibri" pitchFamily="34" charset="-122"/>
                 <a:cs typeface="Calibri" pitchFamily="34" charset="-120"/>
               </a:rPr>
-              <a:t>Design review against SOLID</a:t>
-            </a:r>
-            <a:endParaRPr lang="en-US" sz="1200" dirty="0"/>
-          </a:p>
-          <a:p>
-            <a:pPr marL="342900" indent="-342900">
-              <a:spcAft>
-                <a:spcPts val="600"/>
-              </a:spcAft>
-              <a:buSzPct val="100000"/>
-              <a:buChar char="•"/>
-            </a:pPr>
-            <a:r>
-              <a:rPr lang="en-US" sz="1200" dirty="0">
-                <a:solidFill>
-                  <a:srgbClr val="1D2B2A"/>
-                </a:solidFill>
-                <a:latin typeface="Calibri" pitchFamily="34" charset="0"/>
-                <a:ea typeface="Calibri" pitchFamily="34" charset="-122"/>
-                <a:cs typeface="Calibri" pitchFamily="34" charset="-120"/>
-              </a:rPr>
-              <a:t>Clearer diagrams for the final presentation</a:t>
+              <a:t>The final 30-minute presentation</a:t>
             </a:r>
             <a:endParaRPr lang="en-US" sz="1200" dirty="0"/>
           </a:p>
@@ -8168,7 +8147,7 @@
                 <a:ea typeface="Calibri" pitchFamily="34" charset="-122"/>
                 <a:cs typeface="Calibri" pitchFamily="34" charset="-120"/>
               </a:rPr>
-              <a:t>Save and load the bank's records with files / JSON (weeks 6, 11)</a:t>
+              <a:t>Review the design against SOLID and the design patterns (weeks 10, 11)</a:t>
             </a:r>
             <a:endParaRPr lang="en-US" sz="1400" dirty="0"/>
           </a:p>
@@ -8300,7 +8279,7 @@
                 <a:ea typeface="Calibri" pitchFamily="34" charset="-122"/>
                 <a:cs typeface="Calibri" pitchFamily="34" charset="-120"/>
               </a:rPr>
-              <a:t>Review the design against SOLID and the design patterns (weeks 10, 11)</a:t>
+              <a:t>Apply the feedback from this checkpoint</a:t>
             </a:r>
             <a:endParaRPr lang="en-US" sz="1400" dirty="0"/>
           </a:p>
@@ -8432,7 +8411,7 @@
                 <a:ea typeface="Calibri" pitchFamily="34" charset="-122"/>
                 <a:cs typeface="Calibri" pitchFamily="34" charset="-120"/>
               </a:rPr>
-              <a:t>Apply the feedback from this checkpoint</a:t>
+              <a:t>Prepare the final 30-minute presentation and live demonstration</a:t>
             </a:r>
             <a:endParaRPr lang="en-US" sz="1400" dirty="0"/>
           </a:p>

</xml_diff>